<commit_message>
feat(p02): add 15 standalone runnable Dart code examples and inject GitHub links into PPTX slides
</commit_message>
<xml_diff>
--- a/03_slide_presentasi/PERTEMUAN_02_Modern_Dart_Programming.pptx
+++ b/03_slide_presentasi/PERTEMUAN_02_Modern_Dart_Programming.pptx
@@ -3924,8 +3924,8 @@
         </p:nvSpPr>
         <p:spPr>
           <a:xfrm>
-            <a:off x="5669280" y="2176272"/>
-            <a:ext cx="5486400" cy="3977639"/>
+            <a:off x="5669280" y="2121408"/>
+            <a:ext cx="5486400" cy="3364992"/>
           </a:xfrm>
           <a:prstGeom prst="rect">
             <a:avLst/>
@@ -3939,7 +3939,7 @@
           <a:lstStyle/>
           <a:p>
             <a:pPr>
-              <a:defRPr sz="980">
+              <a:defRPr sz="919">
                 <a:solidFill>
                   <a:srgbClr val="F5F5F5"/>
                 </a:solidFill>
@@ -3993,6 +3993,142 @@
             <a:br/>
             <a:r>
               <a:t>}</a:t>
+            </a:r>
+          </a:p>
+        </p:txBody>
+      </p:sp>
+      <p:sp>
+        <p:nvSpPr>
+          <p:cNvPr id="15" name="Rectangle 14"/>
+          <p:cNvSpPr/>
+          <p:nvPr/>
+        </p:nvSpPr>
+        <p:spPr>
+          <a:xfrm>
+            <a:off x="5660136" y="5669280"/>
+            <a:ext cx="5608015" cy="548640"/>
+          </a:xfrm>
+          <a:prstGeom prst="rect">
+            <a:avLst/>
+          </a:prstGeom>
+          <a:solidFill>
+            <a:srgbClr val="000000"/>
+          </a:solidFill>
+          <a:ln>
+            <a:noFill/>
+          </a:ln>
+        </p:spPr>
+        <p:style>
+          <a:lnRef idx="1">
+            <a:schemeClr val="accent1"/>
+          </a:lnRef>
+          <a:fillRef idx="3">
+            <a:schemeClr val="accent1"/>
+          </a:fillRef>
+          <a:effectRef idx="2">
+            <a:schemeClr val="accent1"/>
+          </a:effectRef>
+          <a:fontRef idx="minor">
+            <a:schemeClr val="lt1"/>
+          </a:fontRef>
+        </p:style>
+        <p:txBody>
+          <a:bodyPr rtlCol="0" anchor="ctr"/>
+          <a:lstStyle/>
+          <a:p>
+            <a:pPr algn="ctr"/>
+          </a:p>
+        </p:txBody>
+      </p:sp>
+      <p:sp>
+        <p:nvSpPr>
+          <p:cNvPr id="16" name="Rectangle 15"/>
+          <p:cNvSpPr/>
+          <p:nvPr/>
+        </p:nvSpPr>
+        <p:spPr>
+          <a:xfrm>
+            <a:off x="5623560" y="5632704"/>
+            <a:ext cx="5608015" cy="548640"/>
+          </a:xfrm>
+          <a:prstGeom prst="rect">
+            <a:avLst/>
+          </a:prstGeom>
+          <a:solidFill>
+            <a:srgbClr val="FFE600"/>
+          </a:solidFill>
+          <a:ln w="25400">
+            <a:solidFill>
+              <a:srgbClr val="000000"/>
+            </a:solidFill>
+          </a:ln>
+        </p:spPr>
+        <p:style>
+          <a:lnRef idx="1">
+            <a:schemeClr val="accent1"/>
+          </a:lnRef>
+          <a:fillRef idx="3">
+            <a:schemeClr val="accent1"/>
+          </a:fillRef>
+          <a:effectRef idx="2">
+            <a:schemeClr val="accent1"/>
+          </a:effectRef>
+          <a:fontRef idx="minor">
+            <a:schemeClr val="lt1"/>
+          </a:fontRef>
+        </p:style>
+        <p:txBody>
+          <a:bodyPr rtlCol="0" anchor="ctr"/>
+          <a:lstStyle/>
+          <a:p>
+            <a:pPr algn="ctr"/>
+          </a:p>
+        </p:txBody>
+      </p:sp>
+      <p:sp>
+        <p:nvSpPr>
+          <p:cNvPr id="17" name="TextBox 16"/>
+          <p:cNvSpPr txBox="1"/>
+          <p:nvPr/>
+        </p:nvSpPr>
+        <p:spPr>
+          <a:xfrm>
+            <a:off x="5696712" y="5660136"/>
+            <a:ext cx="5461711" cy="493776"/>
+          </a:xfrm>
+          <a:prstGeom prst="rect">
+            <a:avLst/>
+          </a:prstGeom>
+          <a:noFill/>
+        </p:spPr>
+        <p:txBody>
+          <a:bodyPr wrap="square">
+            <a:spAutoFit/>
+          </a:bodyPr>
+          <a:lstStyle/>
+          <a:p>
+            <a:r>
+              <a:rPr sz="960" b="1">
+                <a:solidFill>
+                  <a:srgbClr val="000000"/>
+                </a:solidFill>
+                <a:latin typeface="Segoe UI"/>
+                <a:hlinkClick r:id="rId2"/>
+              </a:rPr>
+              <a:t>▶ BUKA KODE LENGKAP DI GITHUB (slide_10_extension_methods.dart)</a:t>
+            </a:r>
+          </a:p>
+          <a:p>
+            <a:pPr>
+              <a:defRPr sz="760">
+                <a:solidFill>
+                  <a:srgbClr val="3C3C3C"/>
+                </a:solidFill>
+                <a:latin typeface="Segoe UI"/>
+              </a:defRPr>
+            </a:pPr>
+            <a:r>
+              <a:t>💡 Buka di browser / salin source code: github.com/antonprafanto/mobile2026</a:t>
             </a:r>
           </a:p>
         </p:txBody>
@@ -4583,8 +4719,8 @@
         </p:nvSpPr>
         <p:spPr>
           <a:xfrm>
-            <a:off x="5669280" y="2176272"/>
-            <a:ext cx="5486400" cy="3977639"/>
+            <a:off x="5669280" y="2121408"/>
+            <a:ext cx="5486400" cy="3364992"/>
           </a:xfrm>
           <a:prstGeom prst="rect">
             <a:avLst/>
@@ -4598,7 +4734,7 @@
           <a:lstStyle/>
           <a:p>
             <a:pPr>
-              <a:defRPr sz="980">
+              <a:defRPr sz="919">
                 <a:solidFill>
                   <a:srgbClr val="F5F5F5"/>
                 </a:solidFill>
@@ -4649,6 +4785,142 @@
             <a:br/>
             <a:r>
               <a:t>}</a:t>
+            </a:r>
+          </a:p>
+        </p:txBody>
+      </p:sp>
+      <p:sp>
+        <p:nvSpPr>
+          <p:cNvPr id="15" name="Rectangle 14"/>
+          <p:cNvSpPr/>
+          <p:nvPr/>
+        </p:nvSpPr>
+        <p:spPr>
+          <a:xfrm>
+            <a:off x="5660136" y="5669280"/>
+            <a:ext cx="5608015" cy="548640"/>
+          </a:xfrm>
+          <a:prstGeom prst="rect">
+            <a:avLst/>
+          </a:prstGeom>
+          <a:solidFill>
+            <a:srgbClr val="000000"/>
+          </a:solidFill>
+          <a:ln>
+            <a:noFill/>
+          </a:ln>
+        </p:spPr>
+        <p:style>
+          <a:lnRef idx="1">
+            <a:schemeClr val="accent1"/>
+          </a:lnRef>
+          <a:fillRef idx="3">
+            <a:schemeClr val="accent1"/>
+          </a:fillRef>
+          <a:effectRef idx="2">
+            <a:schemeClr val="accent1"/>
+          </a:effectRef>
+          <a:fontRef idx="minor">
+            <a:schemeClr val="lt1"/>
+          </a:fontRef>
+        </p:style>
+        <p:txBody>
+          <a:bodyPr rtlCol="0" anchor="ctr"/>
+          <a:lstStyle/>
+          <a:p>
+            <a:pPr algn="ctr"/>
+          </a:p>
+        </p:txBody>
+      </p:sp>
+      <p:sp>
+        <p:nvSpPr>
+          <p:cNvPr id="16" name="Rectangle 15"/>
+          <p:cNvSpPr/>
+          <p:nvPr/>
+        </p:nvSpPr>
+        <p:spPr>
+          <a:xfrm>
+            <a:off x="5623560" y="5632704"/>
+            <a:ext cx="5608015" cy="548640"/>
+          </a:xfrm>
+          <a:prstGeom prst="rect">
+            <a:avLst/>
+          </a:prstGeom>
+          <a:solidFill>
+            <a:srgbClr val="FFE600"/>
+          </a:solidFill>
+          <a:ln w="25400">
+            <a:solidFill>
+              <a:srgbClr val="000000"/>
+            </a:solidFill>
+          </a:ln>
+        </p:spPr>
+        <p:style>
+          <a:lnRef idx="1">
+            <a:schemeClr val="accent1"/>
+          </a:lnRef>
+          <a:fillRef idx="3">
+            <a:schemeClr val="accent1"/>
+          </a:fillRef>
+          <a:effectRef idx="2">
+            <a:schemeClr val="accent1"/>
+          </a:effectRef>
+          <a:fontRef idx="minor">
+            <a:schemeClr val="lt1"/>
+          </a:fontRef>
+        </p:style>
+        <p:txBody>
+          <a:bodyPr rtlCol="0" anchor="ctr"/>
+          <a:lstStyle/>
+          <a:p>
+            <a:pPr algn="ctr"/>
+          </a:p>
+        </p:txBody>
+      </p:sp>
+      <p:sp>
+        <p:nvSpPr>
+          <p:cNvPr id="17" name="TextBox 16"/>
+          <p:cNvSpPr txBox="1"/>
+          <p:nvPr/>
+        </p:nvSpPr>
+        <p:spPr>
+          <a:xfrm>
+            <a:off x="5696712" y="5660136"/>
+            <a:ext cx="5461711" cy="493776"/>
+          </a:xfrm>
+          <a:prstGeom prst="rect">
+            <a:avLst/>
+          </a:prstGeom>
+          <a:noFill/>
+        </p:spPr>
+        <p:txBody>
+          <a:bodyPr wrap="square">
+            <a:spAutoFit/>
+          </a:bodyPr>
+          <a:lstStyle/>
+          <a:p>
+            <a:r>
+              <a:rPr sz="960" b="1">
+                <a:solidFill>
+                  <a:srgbClr val="000000"/>
+                </a:solidFill>
+                <a:latin typeface="Segoe UI"/>
+                <a:hlinkClick r:id="rId2"/>
+              </a:rPr>
+              <a:t>▶ BUKA KODE LENGKAP DI GITHUB (slide_11_collections_list_map_set.dart)</a:t>
+            </a:r>
+          </a:p>
+          <a:p>
+            <a:pPr>
+              <a:defRPr sz="760">
+                <a:solidFill>
+                  <a:srgbClr val="3C3C3C"/>
+                </a:solidFill>
+                <a:latin typeface="Segoe UI"/>
+              </a:defRPr>
+            </a:pPr>
+            <a:r>
+              <a:t>💡 Buka di browser / salin source code: github.com/antonprafanto/mobile2026</a:t>
             </a:r>
           </a:p>
         </p:txBody>
@@ -5255,8 +5527,8 @@
         </p:nvSpPr>
         <p:spPr>
           <a:xfrm>
-            <a:off x="5669280" y="2176272"/>
-            <a:ext cx="5486400" cy="3977639"/>
+            <a:off x="5669280" y="2121408"/>
+            <a:ext cx="5486400" cy="3364992"/>
           </a:xfrm>
           <a:prstGeom prst="rect">
             <a:avLst/>
@@ -5270,7 +5542,7 @@
           <a:lstStyle/>
           <a:p>
             <a:pPr>
-              <a:defRPr sz="980">
+              <a:defRPr sz="919">
                 <a:solidFill>
                   <a:srgbClr val="F5F5F5"/>
                 </a:solidFill>
@@ -5313,6 +5585,142 @@
             <a:br/>
             <a:r>
               <a:t>}</a:t>
+            </a:r>
+          </a:p>
+        </p:txBody>
+      </p:sp>
+      <p:sp>
+        <p:nvSpPr>
+          <p:cNvPr id="15" name="Rectangle 14"/>
+          <p:cNvSpPr/>
+          <p:nvPr/>
+        </p:nvSpPr>
+        <p:spPr>
+          <a:xfrm>
+            <a:off x="5660136" y="5669280"/>
+            <a:ext cx="5608015" cy="548640"/>
+          </a:xfrm>
+          <a:prstGeom prst="rect">
+            <a:avLst/>
+          </a:prstGeom>
+          <a:solidFill>
+            <a:srgbClr val="000000"/>
+          </a:solidFill>
+          <a:ln>
+            <a:noFill/>
+          </a:ln>
+        </p:spPr>
+        <p:style>
+          <a:lnRef idx="1">
+            <a:schemeClr val="accent1"/>
+          </a:lnRef>
+          <a:fillRef idx="3">
+            <a:schemeClr val="accent1"/>
+          </a:fillRef>
+          <a:effectRef idx="2">
+            <a:schemeClr val="accent1"/>
+          </a:effectRef>
+          <a:fontRef idx="minor">
+            <a:schemeClr val="lt1"/>
+          </a:fontRef>
+        </p:style>
+        <p:txBody>
+          <a:bodyPr rtlCol="0" anchor="ctr"/>
+          <a:lstStyle/>
+          <a:p>
+            <a:pPr algn="ctr"/>
+          </a:p>
+        </p:txBody>
+      </p:sp>
+      <p:sp>
+        <p:nvSpPr>
+          <p:cNvPr id="16" name="Rectangle 15"/>
+          <p:cNvSpPr/>
+          <p:nvPr/>
+        </p:nvSpPr>
+        <p:spPr>
+          <a:xfrm>
+            <a:off x="5623560" y="5632704"/>
+            <a:ext cx="5608015" cy="548640"/>
+          </a:xfrm>
+          <a:prstGeom prst="rect">
+            <a:avLst/>
+          </a:prstGeom>
+          <a:solidFill>
+            <a:srgbClr val="FFE600"/>
+          </a:solidFill>
+          <a:ln w="25400">
+            <a:solidFill>
+              <a:srgbClr val="000000"/>
+            </a:solidFill>
+          </a:ln>
+        </p:spPr>
+        <p:style>
+          <a:lnRef idx="1">
+            <a:schemeClr val="accent1"/>
+          </a:lnRef>
+          <a:fillRef idx="3">
+            <a:schemeClr val="accent1"/>
+          </a:fillRef>
+          <a:effectRef idx="2">
+            <a:schemeClr val="accent1"/>
+          </a:effectRef>
+          <a:fontRef idx="minor">
+            <a:schemeClr val="lt1"/>
+          </a:fontRef>
+        </p:style>
+        <p:txBody>
+          <a:bodyPr rtlCol="0" anchor="ctr"/>
+          <a:lstStyle/>
+          <a:p>
+            <a:pPr algn="ctr"/>
+          </a:p>
+        </p:txBody>
+      </p:sp>
+      <p:sp>
+        <p:nvSpPr>
+          <p:cNvPr id="17" name="TextBox 16"/>
+          <p:cNvSpPr txBox="1"/>
+          <p:nvPr/>
+        </p:nvSpPr>
+        <p:spPr>
+          <a:xfrm>
+            <a:off x="5696712" y="5660136"/>
+            <a:ext cx="5461711" cy="493776"/>
+          </a:xfrm>
+          <a:prstGeom prst="rect">
+            <a:avLst/>
+          </a:prstGeom>
+          <a:noFill/>
+        </p:spPr>
+        <p:txBody>
+          <a:bodyPr wrap="square">
+            <a:spAutoFit/>
+          </a:bodyPr>
+          <a:lstStyle/>
+          <a:p>
+            <a:r>
+              <a:rPr sz="960" b="1">
+                <a:solidFill>
+                  <a:srgbClr val="000000"/>
+                </a:solidFill>
+                <a:latin typeface="Segoe UI"/>
+                <a:hlinkClick r:id="rId2"/>
+              </a:rPr>
+              <a:t>▶ BUKA KODE LENGKAP DI GITHUB (slide_12_reactive_collections.dart)</a:t>
+            </a:r>
+          </a:p>
+          <a:p>
+            <a:pPr>
+              <a:defRPr sz="760">
+                <a:solidFill>
+                  <a:srgbClr val="3C3C3C"/>
+                </a:solidFill>
+                <a:latin typeface="Segoe UI"/>
+              </a:defRPr>
+            </a:pPr>
+            <a:r>
+              <a:t>💡 Buka di browser / salin source code: github.com/antonprafanto/mobile2026</a:t>
             </a:r>
           </a:p>
         </p:txBody>
@@ -5919,8 +6327,8 @@
         </p:nvSpPr>
         <p:spPr>
           <a:xfrm>
-            <a:off x="5669280" y="2176272"/>
-            <a:ext cx="5486400" cy="3977639"/>
+            <a:off x="5669280" y="2121408"/>
+            <a:ext cx="5486400" cy="3364992"/>
           </a:xfrm>
           <a:prstGeom prst="rect">
             <a:avLst/>
@@ -5934,7 +6342,7 @@
           <a:lstStyle/>
           <a:p>
             <a:pPr>
-              <a:defRPr sz="980">
+              <a:defRPr sz="919">
                 <a:solidFill>
                   <a:srgbClr val="F5F5F5"/>
                 </a:solidFill>
@@ -5984,6 +6392,142 @@
             <a:br/>
             <a:r>
               <a:t>}</a:t>
+            </a:r>
+          </a:p>
+        </p:txBody>
+      </p:sp>
+      <p:sp>
+        <p:nvSpPr>
+          <p:cNvPr id="15" name="Rectangle 14"/>
+          <p:cNvSpPr/>
+          <p:nvPr/>
+        </p:nvSpPr>
+        <p:spPr>
+          <a:xfrm>
+            <a:off x="5660136" y="5669280"/>
+            <a:ext cx="5608015" cy="548640"/>
+          </a:xfrm>
+          <a:prstGeom prst="rect">
+            <a:avLst/>
+          </a:prstGeom>
+          <a:solidFill>
+            <a:srgbClr val="000000"/>
+          </a:solidFill>
+          <a:ln>
+            <a:noFill/>
+          </a:ln>
+        </p:spPr>
+        <p:style>
+          <a:lnRef idx="1">
+            <a:schemeClr val="accent1"/>
+          </a:lnRef>
+          <a:fillRef idx="3">
+            <a:schemeClr val="accent1"/>
+          </a:fillRef>
+          <a:effectRef idx="2">
+            <a:schemeClr val="accent1"/>
+          </a:effectRef>
+          <a:fontRef idx="minor">
+            <a:schemeClr val="lt1"/>
+          </a:fontRef>
+        </p:style>
+        <p:txBody>
+          <a:bodyPr rtlCol="0" anchor="ctr"/>
+          <a:lstStyle/>
+          <a:p>
+            <a:pPr algn="ctr"/>
+          </a:p>
+        </p:txBody>
+      </p:sp>
+      <p:sp>
+        <p:nvSpPr>
+          <p:cNvPr id="16" name="Rectangle 15"/>
+          <p:cNvSpPr/>
+          <p:nvPr/>
+        </p:nvSpPr>
+        <p:spPr>
+          <a:xfrm>
+            <a:off x="5623560" y="5632704"/>
+            <a:ext cx="5608015" cy="548640"/>
+          </a:xfrm>
+          <a:prstGeom prst="rect">
+            <a:avLst/>
+          </a:prstGeom>
+          <a:solidFill>
+            <a:srgbClr val="FFE600"/>
+          </a:solidFill>
+          <a:ln w="25400">
+            <a:solidFill>
+              <a:srgbClr val="000000"/>
+            </a:solidFill>
+          </a:ln>
+        </p:spPr>
+        <p:style>
+          <a:lnRef idx="1">
+            <a:schemeClr val="accent1"/>
+          </a:lnRef>
+          <a:fillRef idx="3">
+            <a:schemeClr val="accent1"/>
+          </a:fillRef>
+          <a:effectRef idx="2">
+            <a:schemeClr val="accent1"/>
+          </a:effectRef>
+          <a:fontRef idx="minor">
+            <a:schemeClr val="lt1"/>
+          </a:fontRef>
+        </p:style>
+        <p:txBody>
+          <a:bodyPr rtlCol="0" anchor="ctr"/>
+          <a:lstStyle/>
+          <a:p>
+            <a:pPr algn="ctr"/>
+          </a:p>
+        </p:txBody>
+      </p:sp>
+      <p:sp>
+        <p:nvSpPr>
+          <p:cNvPr id="17" name="TextBox 16"/>
+          <p:cNvSpPr txBox="1"/>
+          <p:nvPr/>
+        </p:nvSpPr>
+        <p:spPr>
+          <a:xfrm>
+            <a:off x="5696712" y="5660136"/>
+            <a:ext cx="5461711" cy="493776"/>
+          </a:xfrm>
+          <a:prstGeom prst="rect">
+            <a:avLst/>
+          </a:prstGeom>
+          <a:noFill/>
+        </p:spPr>
+        <p:txBody>
+          <a:bodyPr wrap="square">
+            <a:spAutoFit/>
+          </a:bodyPr>
+          <a:lstStyle/>
+          <a:p>
+            <a:r>
+              <a:rPr sz="960" b="1">
+                <a:solidFill>
+                  <a:srgbClr val="000000"/>
+                </a:solidFill>
+                <a:latin typeface="Segoe UI"/>
+                <a:hlinkClick r:id="rId2"/>
+              </a:rPr>
+              <a:t>▶ BUKA KODE LENGKAP DI GITHUB (slide_13_dilema_sync_vs_async.dart)</a:t>
+            </a:r>
+          </a:p>
+          <a:p>
+            <a:pPr>
+              <a:defRPr sz="760">
+                <a:solidFill>
+                  <a:srgbClr val="3C3C3C"/>
+                </a:solidFill>
+                <a:latin typeface="Segoe UI"/>
+              </a:defRPr>
+            </a:pPr>
+            <a:r>
+              <a:t>💡 Buka di browser / salin source code: github.com/antonprafanto/mobile2026</a:t>
             </a:r>
           </a:p>
         </p:txBody>
@@ -6590,8 +7134,8 @@
         </p:nvSpPr>
         <p:spPr>
           <a:xfrm>
-            <a:off x="5669280" y="2176272"/>
-            <a:ext cx="5486400" cy="3977639"/>
+            <a:off x="5669280" y="2121408"/>
+            <a:ext cx="5486400" cy="3364992"/>
           </a:xfrm>
           <a:prstGeom prst="rect">
             <a:avLst/>
@@ -6605,7 +7149,7 @@
           <a:lstStyle/>
           <a:p>
             <a:pPr>
-              <a:defRPr sz="980">
+              <a:defRPr sz="919">
                 <a:solidFill>
                   <a:srgbClr val="F5F5F5"/>
                 </a:solidFill>
@@ -6671,6 +7215,142 @@
             <a:br/>
             <a:r>
               <a:t>}</a:t>
+            </a:r>
+          </a:p>
+        </p:txBody>
+      </p:sp>
+      <p:sp>
+        <p:nvSpPr>
+          <p:cNvPr id="15" name="Rectangle 14"/>
+          <p:cNvSpPr/>
+          <p:nvPr/>
+        </p:nvSpPr>
+        <p:spPr>
+          <a:xfrm>
+            <a:off x="5660136" y="5669280"/>
+            <a:ext cx="5608015" cy="548640"/>
+          </a:xfrm>
+          <a:prstGeom prst="rect">
+            <a:avLst/>
+          </a:prstGeom>
+          <a:solidFill>
+            <a:srgbClr val="000000"/>
+          </a:solidFill>
+          <a:ln>
+            <a:noFill/>
+          </a:ln>
+        </p:spPr>
+        <p:style>
+          <a:lnRef idx="1">
+            <a:schemeClr val="accent1"/>
+          </a:lnRef>
+          <a:fillRef idx="3">
+            <a:schemeClr val="accent1"/>
+          </a:fillRef>
+          <a:effectRef idx="2">
+            <a:schemeClr val="accent1"/>
+          </a:effectRef>
+          <a:fontRef idx="minor">
+            <a:schemeClr val="lt1"/>
+          </a:fontRef>
+        </p:style>
+        <p:txBody>
+          <a:bodyPr rtlCol="0" anchor="ctr"/>
+          <a:lstStyle/>
+          <a:p>
+            <a:pPr algn="ctr"/>
+          </a:p>
+        </p:txBody>
+      </p:sp>
+      <p:sp>
+        <p:nvSpPr>
+          <p:cNvPr id="16" name="Rectangle 15"/>
+          <p:cNvSpPr/>
+          <p:nvPr/>
+        </p:nvSpPr>
+        <p:spPr>
+          <a:xfrm>
+            <a:off x="5623560" y="5632704"/>
+            <a:ext cx="5608015" cy="548640"/>
+          </a:xfrm>
+          <a:prstGeom prst="rect">
+            <a:avLst/>
+          </a:prstGeom>
+          <a:solidFill>
+            <a:srgbClr val="FFE600"/>
+          </a:solidFill>
+          <a:ln w="25400">
+            <a:solidFill>
+              <a:srgbClr val="000000"/>
+            </a:solidFill>
+          </a:ln>
+        </p:spPr>
+        <p:style>
+          <a:lnRef idx="1">
+            <a:schemeClr val="accent1"/>
+          </a:lnRef>
+          <a:fillRef idx="3">
+            <a:schemeClr val="accent1"/>
+          </a:fillRef>
+          <a:effectRef idx="2">
+            <a:schemeClr val="accent1"/>
+          </a:effectRef>
+          <a:fontRef idx="minor">
+            <a:schemeClr val="lt1"/>
+          </a:fontRef>
+        </p:style>
+        <p:txBody>
+          <a:bodyPr rtlCol="0" anchor="ctr"/>
+          <a:lstStyle/>
+          <a:p>
+            <a:pPr algn="ctr"/>
+          </a:p>
+        </p:txBody>
+      </p:sp>
+      <p:sp>
+        <p:nvSpPr>
+          <p:cNvPr id="17" name="TextBox 16"/>
+          <p:cNvSpPr txBox="1"/>
+          <p:nvPr/>
+        </p:nvSpPr>
+        <p:spPr>
+          <a:xfrm>
+            <a:off x="5696712" y="5660136"/>
+            <a:ext cx="5461711" cy="493776"/>
+          </a:xfrm>
+          <a:prstGeom prst="rect">
+            <a:avLst/>
+          </a:prstGeom>
+          <a:noFill/>
+        </p:spPr>
+        <p:txBody>
+          <a:bodyPr wrap="square">
+            <a:spAutoFit/>
+          </a:bodyPr>
+          <a:lstStyle/>
+          <a:p>
+            <a:r>
+              <a:rPr sz="960" b="1">
+                <a:solidFill>
+                  <a:srgbClr val="000000"/>
+                </a:solidFill>
+                <a:latin typeface="Segoe UI"/>
+                <a:hlinkClick r:id="rId2"/>
+              </a:rPr>
+              <a:t>▶ BUKA KODE LENGKAP DI GITHUB (slide_14_future_async_await.dart)</a:t>
+            </a:r>
+          </a:p>
+          <a:p>
+            <a:pPr>
+              <a:defRPr sz="760">
+                <a:solidFill>
+                  <a:srgbClr val="3C3C3C"/>
+                </a:solidFill>
+                <a:latin typeface="Segoe UI"/>
+              </a:defRPr>
+            </a:pPr>
+            <a:r>
+              <a:t>💡 Buka di browser / salin source code: github.com/antonprafanto/mobile2026</a:t>
             </a:r>
           </a:p>
         </p:txBody>
@@ -7277,8 +7957,8 @@
         </p:nvSpPr>
         <p:spPr>
           <a:xfrm>
-            <a:off x="5669280" y="2176272"/>
-            <a:ext cx="5486400" cy="3977639"/>
+            <a:off x="5669280" y="2121408"/>
+            <a:ext cx="5486400" cy="3364992"/>
           </a:xfrm>
           <a:prstGeom prst="rect">
             <a:avLst/>
@@ -7292,7 +7972,7 @@
           <a:lstStyle/>
           <a:p>
             <a:pPr>
-              <a:defRPr sz="980">
+              <a:defRPr sz="919">
                 <a:solidFill>
                   <a:srgbClr val="F5F5F5"/>
                 </a:solidFill>
@@ -7354,6 +8034,142 @@
             <a:br/>
             <a:r>
               <a:t>}</a:t>
+            </a:r>
+          </a:p>
+        </p:txBody>
+      </p:sp>
+      <p:sp>
+        <p:nvSpPr>
+          <p:cNvPr id="15" name="Rectangle 14"/>
+          <p:cNvSpPr/>
+          <p:nvPr/>
+        </p:nvSpPr>
+        <p:spPr>
+          <a:xfrm>
+            <a:off x="5660136" y="5669280"/>
+            <a:ext cx="5608015" cy="548640"/>
+          </a:xfrm>
+          <a:prstGeom prst="rect">
+            <a:avLst/>
+          </a:prstGeom>
+          <a:solidFill>
+            <a:srgbClr val="000000"/>
+          </a:solidFill>
+          <a:ln>
+            <a:noFill/>
+          </a:ln>
+        </p:spPr>
+        <p:style>
+          <a:lnRef idx="1">
+            <a:schemeClr val="accent1"/>
+          </a:lnRef>
+          <a:fillRef idx="3">
+            <a:schemeClr val="accent1"/>
+          </a:fillRef>
+          <a:effectRef idx="2">
+            <a:schemeClr val="accent1"/>
+          </a:effectRef>
+          <a:fontRef idx="minor">
+            <a:schemeClr val="lt1"/>
+          </a:fontRef>
+        </p:style>
+        <p:txBody>
+          <a:bodyPr rtlCol="0" anchor="ctr"/>
+          <a:lstStyle/>
+          <a:p>
+            <a:pPr algn="ctr"/>
+          </a:p>
+        </p:txBody>
+      </p:sp>
+      <p:sp>
+        <p:nvSpPr>
+          <p:cNvPr id="16" name="Rectangle 15"/>
+          <p:cNvSpPr/>
+          <p:nvPr/>
+        </p:nvSpPr>
+        <p:spPr>
+          <a:xfrm>
+            <a:off x="5623560" y="5632704"/>
+            <a:ext cx="5608015" cy="548640"/>
+          </a:xfrm>
+          <a:prstGeom prst="rect">
+            <a:avLst/>
+          </a:prstGeom>
+          <a:solidFill>
+            <a:srgbClr val="FFE600"/>
+          </a:solidFill>
+          <a:ln w="25400">
+            <a:solidFill>
+              <a:srgbClr val="000000"/>
+            </a:solidFill>
+          </a:ln>
+        </p:spPr>
+        <p:style>
+          <a:lnRef idx="1">
+            <a:schemeClr val="accent1"/>
+          </a:lnRef>
+          <a:fillRef idx="3">
+            <a:schemeClr val="accent1"/>
+          </a:fillRef>
+          <a:effectRef idx="2">
+            <a:schemeClr val="accent1"/>
+          </a:effectRef>
+          <a:fontRef idx="minor">
+            <a:schemeClr val="lt1"/>
+          </a:fontRef>
+        </p:style>
+        <p:txBody>
+          <a:bodyPr rtlCol="0" anchor="ctr"/>
+          <a:lstStyle/>
+          <a:p>
+            <a:pPr algn="ctr"/>
+          </a:p>
+        </p:txBody>
+      </p:sp>
+      <p:sp>
+        <p:nvSpPr>
+          <p:cNvPr id="17" name="TextBox 16"/>
+          <p:cNvSpPr txBox="1"/>
+          <p:nvPr/>
+        </p:nvSpPr>
+        <p:spPr>
+          <a:xfrm>
+            <a:off x="5696712" y="5660136"/>
+            <a:ext cx="5461711" cy="493776"/>
+          </a:xfrm>
+          <a:prstGeom prst="rect">
+            <a:avLst/>
+          </a:prstGeom>
+          <a:noFill/>
+        </p:spPr>
+        <p:txBody>
+          <a:bodyPr wrap="square">
+            <a:spAutoFit/>
+          </a:bodyPr>
+          <a:lstStyle/>
+          <a:p>
+            <a:r>
+              <a:rPr sz="960" b="1">
+                <a:solidFill>
+                  <a:srgbClr val="000000"/>
+                </a:solidFill>
+                <a:latin typeface="Segoe UI"/>
+                <a:hlinkClick r:id="rId2"/>
+              </a:rPr>
+              <a:t>▶ BUKA KODE LENGKAP DI GITHUB (slide_15_stream_reactive_data.dart)</a:t>
+            </a:r>
+          </a:p>
+          <a:p>
+            <a:pPr>
+              <a:defRPr sz="760">
+                <a:solidFill>
+                  <a:srgbClr val="3C3C3C"/>
+                </a:solidFill>
+                <a:latin typeface="Segoe UI"/>
+              </a:defRPr>
+            </a:pPr>
+            <a:r>
+              <a:t>💡 Buka di browser / salin source code: github.com/antonprafanto/mobile2026</a:t>
             </a:r>
           </a:p>
         </p:txBody>
@@ -7756,8 +8572,8 @@
         </p:nvSpPr>
         <p:spPr>
           <a:xfrm>
-            <a:off x="1188720" y="2240280"/>
-            <a:ext cx="9784080" cy="3931920"/>
+            <a:off x="1188720" y="2212848"/>
+            <a:ext cx="9784080" cy="3291840"/>
           </a:xfrm>
           <a:prstGeom prst="rect">
             <a:avLst/>
@@ -7772,9 +8588,9 @@
           <a:p>
             <a:pPr>
               <a:spcAft>
-                <a:spcPts val="500"/>
+                <a:spcPts val="400"/>
               </a:spcAft>
-              <a:defRPr sz="1450" b="1">
+              <a:defRPr sz="1350" b="1">
                 <a:solidFill>
                   <a:srgbClr val="000000"/>
                 </a:solidFill>
@@ -7788,9 +8604,9 @@
           <a:p>
             <a:pPr>
               <a:spcAft>
-                <a:spcPts val="300"/>
+                <a:spcPts val="200"/>
               </a:spcAft>
-              <a:defRPr sz="1100">
+              <a:defRPr sz="1050">
                 <a:solidFill>
                   <a:srgbClr val="1E1E1E"/>
                 </a:solidFill>
@@ -7804,9 +8620,9 @@
           <a:p>
             <a:pPr>
               <a:spcAft>
-                <a:spcPts val="300"/>
+                <a:spcPts val="200"/>
               </a:spcAft>
-              <a:defRPr sz="1100">
+              <a:defRPr sz="1050">
                 <a:solidFill>
                   <a:srgbClr val="1E1E1E"/>
                 </a:solidFill>
@@ -7820,9 +8636,9 @@
           <a:p>
             <a:pPr>
               <a:spcAft>
-                <a:spcPts val="300"/>
+                <a:spcPts val="200"/>
               </a:spcAft>
-              <a:defRPr sz="1100">
+              <a:defRPr sz="1050">
                 <a:solidFill>
                   <a:srgbClr val="1E1E1E"/>
                 </a:solidFill>
@@ -7836,9 +8652,9 @@
           <a:p>
             <a:pPr>
               <a:spcAft>
-                <a:spcPts val="300"/>
+                <a:spcPts val="200"/>
               </a:spcAft>
-              <a:defRPr sz="1100">
+              <a:defRPr sz="1050">
                 <a:solidFill>
                   <a:srgbClr val="1E1E1E"/>
                 </a:solidFill>
@@ -7852,9 +8668,9 @@
           <a:p>
             <a:pPr>
               <a:spcAft>
-                <a:spcPts val="300"/>
+                <a:spcPts val="200"/>
               </a:spcAft>
-              <a:defRPr sz="1100">
+              <a:defRPr sz="1050">
                 <a:solidFill>
                   <a:srgbClr val="1E1E1E"/>
                 </a:solidFill>
@@ -7868,9 +8684,9 @@
           <a:p>
             <a:pPr>
               <a:spcAft>
-                <a:spcPts val="300"/>
+                <a:spcPts val="200"/>
               </a:spcAft>
-              <a:defRPr sz="1100">
+              <a:defRPr sz="1050">
                 <a:solidFill>
                   <a:srgbClr val="1E1E1E"/>
                 </a:solidFill>
@@ -7882,9 +8698,8 @@
             </a:r>
           </a:p>
           <a:p>
-            <a:br/>
-            <a:pPr>
-              <a:defRPr sz="1150" b="1">
+            <a:pPr>
+              <a:defRPr sz="1100" b="1">
                 <a:solidFill>
                   <a:srgbClr val="00823C"/>
                 </a:solidFill>
@@ -7892,11 +8707,143 @@
               </a:defRPr>
             </a:pPr>
             <a:r>
-              <a:t>✔ Kriteria Keberhasilan (Tunjukkan ke Dosen/Asisten Lab):</a:t>
-            </a:r>
-            <a:br/>
-            <a:r>
-              <a:t>Tunjukkan hasil eksekusi terminal di DartPad/VS Code kepada Dosen atau Asisten Lab untuk mendapatkan checklist nilai modul 2.</a:t>
+              <a:t>✔ Kriteria Keberhasilan (Tunjukkan ke Dosen/Asisten Lab): Tunjukkan hasil eksekusi terminal di DartPad/VS Code kepada Dosen atau Asisten Lab untuk mendapatkan checklist nilai modul 2.</a:t>
+            </a:r>
+          </a:p>
+        </p:txBody>
+      </p:sp>
+      <p:sp>
+        <p:nvSpPr>
+          <p:cNvPr id="12" name="Rectangle 11"/>
+          <p:cNvSpPr/>
+          <p:nvPr/>
+        </p:nvSpPr>
+        <p:spPr>
+          <a:xfrm>
+            <a:off x="1225296" y="5669280"/>
+            <a:ext cx="9784080" cy="502920"/>
+          </a:xfrm>
+          <a:prstGeom prst="rect">
+            <a:avLst/>
+          </a:prstGeom>
+          <a:solidFill>
+            <a:srgbClr val="000000"/>
+          </a:solidFill>
+          <a:ln>
+            <a:noFill/>
+          </a:ln>
+        </p:spPr>
+        <p:style>
+          <a:lnRef idx="1">
+            <a:schemeClr val="accent1"/>
+          </a:lnRef>
+          <a:fillRef idx="3">
+            <a:schemeClr val="accent1"/>
+          </a:fillRef>
+          <a:effectRef idx="2">
+            <a:schemeClr val="accent1"/>
+          </a:effectRef>
+          <a:fontRef idx="minor">
+            <a:schemeClr val="lt1"/>
+          </a:fontRef>
+        </p:style>
+        <p:txBody>
+          <a:bodyPr rtlCol="0" anchor="ctr"/>
+          <a:lstStyle/>
+          <a:p>
+            <a:pPr algn="ctr"/>
+          </a:p>
+        </p:txBody>
+      </p:sp>
+      <p:sp>
+        <p:nvSpPr>
+          <p:cNvPr id="13" name="Rectangle 12"/>
+          <p:cNvSpPr/>
+          <p:nvPr/>
+        </p:nvSpPr>
+        <p:spPr>
+          <a:xfrm>
+            <a:off x="1188720" y="5632704"/>
+            <a:ext cx="9784080" cy="502920"/>
+          </a:xfrm>
+          <a:prstGeom prst="rect">
+            <a:avLst/>
+          </a:prstGeom>
+          <a:solidFill>
+            <a:srgbClr val="4ADE80"/>
+          </a:solidFill>
+          <a:ln w="25400">
+            <a:solidFill>
+              <a:srgbClr val="000000"/>
+            </a:solidFill>
+          </a:ln>
+        </p:spPr>
+        <p:style>
+          <a:lnRef idx="1">
+            <a:schemeClr val="accent1"/>
+          </a:lnRef>
+          <a:fillRef idx="3">
+            <a:schemeClr val="accent1"/>
+          </a:fillRef>
+          <a:effectRef idx="2">
+            <a:schemeClr val="accent1"/>
+          </a:effectRef>
+          <a:fontRef idx="minor">
+            <a:schemeClr val="lt1"/>
+          </a:fontRef>
+        </p:style>
+        <p:txBody>
+          <a:bodyPr rtlCol="0" anchor="ctr"/>
+          <a:lstStyle/>
+          <a:p>
+            <a:pPr algn="ctr"/>
+          </a:p>
+        </p:txBody>
+      </p:sp>
+      <p:sp>
+        <p:nvSpPr>
+          <p:cNvPr id="14" name="TextBox 13"/>
+          <p:cNvSpPr txBox="1"/>
+          <p:nvPr/>
+        </p:nvSpPr>
+        <p:spPr>
+          <a:xfrm>
+            <a:off x="1261872" y="5660136"/>
+            <a:ext cx="9637776" cy="448056"/>
+          </a:xfrm>
+          <a:prstGeom prst="rect">
+            <a:avLst/>
+          </a:prstGeom>
+          <a:noFill/>
+        </p:spPr>
+        <p:txBody>
+          <a:bodyPr wrap="square">
+            <a:spAutoFit/>
+          </a:bodyPr>
+          <a:lstStyle/>
+          <a:p>
+            <a:r>
+              <a:rPr sz="1000" b="1">
+                <a:solidFill>
+                  <a:srgbClr val="000000"/>
+                </a:solidFill>
+                <a:latin typeface="Segoe UI"/>
+                <a:hlinkClick r:id="rId2"/>
+              </a:rPr>
+              <a:t>▶ BUKA KODE SOLUSI LENGKAP LAB QUEST DI GITHUB (slide_16_lab_quest_tugas_02.dart)</a:t>
+            </a:r>
+          </a:p>
+          <a:p>
+            <a:pPr>
+              <a:defRPr sz="800">
+                <a:solidFill>
+                  <a:srgbClr val="3C3C3C"/>
+                </a:solidFill>
+                <a:latin typeface="Segoe UI"/>
+              </a:defRPr>
+            </a:pPr>
+            <a:r>
+              <a:t>💡 Buka di browser / salin source code: github.com/antonprafanto/mobile2026</a:t>
             </a:r>
           </a:p>
         </p:txBody>
@@ -8487,8 +9434,8 @@
         </p:nvSpPr>
         <p:spPr>
           <a:xfrm>
-            <a:off x="5669280" y="2176272"/>
-            <a:ext cx="5486400" cy="3977639"/>
+            <a:off x="5669280" y="2121408"/>
+            <a:ext cx="5486400" cy="3364992"/>
           </a:xfrm>
           <a:prstGeom prst="rect">
             <a:avLst/>
@@ -8502,7 +9449,7 @@
           <a:lstStyle/>
           <a:p>
             <a:pPr>
-              <a:defRPr sz="980">
+              <a:defRPr sz="919">
                 <a:solidFill>
                   <a:srgbClr val="F5F5F5"/>
                 </a:solidFill>
@@ -8541,6 +9488,142 @@
             <a:br/>
             <a:r>
               <a:t>// $ dart run latihan.dart</a:t>
+            </a:r>
+          </a:p>
+        </p:txBody>
+      </p:sp>
+      <p:sp>
+        <p:nvSpPr>
+          <p:cNvPr id="15" name="Rectangle 14"/>
+          <p:cNvSpPr/>
+          <p:nvPr/>
+        </p:nvSpPr>
+        <p:spPr>
+          <a:xfrm>
+            <a:off x="5660136" y="5669280"/>
+            <a:ext cx="5608015" cy="548640"/>
+          </a:xfrm>
+          <a:prstGeom prst="rect">
+            <a:avLst/>
+          </a:prstGeom>
+          <a:solidFill>
+            <a:srgbClr val="000000"/>
+          </a:solidFill>
+          <a:ln>
+            <a:noFill/>
+          </a:ln>
+        </p:spPr>
+        <p:style>
+          <a:lnRef idx="1">
+            <a:schemeClr val="accent1"/>
+          </a:lnRef>
+          <a:fillRef idx="3">
+            <a:schemeClr val="accent1"/>
+          </a:fillRef>
+          <a:effectRef idx="2">
+            <a:schemeClr val="accent1"/>
+          </a:effectRef>
+          <a:fontRef idx="minor">
+            <a:schemeClr val="lt1"/>
+          </a:fontRef>
+        </p:style>
+        <p:txBody>
+          <a:bodyPr rtlCol="0" anchor="ctr"/>
+          <a:lstStyle/>
+          <a:p>
+            <a:pPr algn="ctr"/>
+          </a:p>
+        </p:txBody>
+      </p:sp>
+      <p:sp>
+        <p:nvSpPr>
+          <p:cNvPr id="16" name="Rectangle 15"/>
+          <p:cNvSpPr/>
+          <p:nvPr/>
+        </p:nvSpPr>
+        <p:spPr>
+          <a:xfrm>
+            <a:off x="5623560" y="5632704"/>
+            <a:ext cx="5608015" cy="548640"/>
+          </a:xfrm>
+          <a:prstGeom prst="rect">
+            <a:avLst/>
+          </a:prstGeom>
+          <a:solidFill>
+            <a:srgbClr val="FFE600"/>
+          </a:solidFill>
+          <a:ln w="25400">
+            <a:solidFill>
+              <a:srgbClr val="000000"/>
+            </a:solidFill>
+          </a:ln>
+        </p:spPr>
+        <p:style>
+          <a:lnRef idx="1">
+            <a:schemeClr val="accent1"/>
+          </a:lnRef>
+          <a:fillRef idx="3">
+            <a:schemeClr val="accent1"/>
+          </a:fillRef>
+          <a:effectRef idx="2">
+            <a:schemeClr val="accent1"/>
+          </a:effectRef>
+          <a:fontRef idx="minor">
+            <a:schemeClr val="lt1"/>
+          </a:fontRef>
+        </p:style>
+        <p:txBody>
+          <a:bodyPr rtlCol="0" anchor="ctr"/>
+          <a:lstStyle/>
+          <a:p>
+            <a:pPr algn="ctr"/>
+          </a:p>
+        </p:txBody>
+      </p:sp>
+      <p:sp>
+        <p:nvSpPr>
+          <p:cNvPr id="17" name="TextBox 16"/>
+          <p:cNvSpPr txBox="1"/>
+          <p:nvPr/>
+        </p:nvSpPr>
+        <p:spPr>
+          <a:xfrm>
+            <a:off x="5696712" y="5660136"/>
+            <a:ext cx="5461711" cy="493776"/>
+          </a:xfrm>
+          <a:prstGeom prst="rect">
+            <a:avLst/>
+          </a:prstGeom>
+          <a:noFill/>
+        </p:spPr>
+        <p:txBody>
+          <a:bodyPr wrap="square">
+            <a:spAutoFit/>
+          </a:bodyPr>
+          <a:lstStyle/>
+          <a:p>
+            <a:r>
+              <a:rPr sz="960" b="1">
+                <a:solidFill>
+                  <a:srgbClr val="000000"/>
+                </a:solidFill>
+                <a:latin typeface="Segoe UI"/>
+                <a:hlinkClick r:id="rId2"/>
+              </a:rPr>
+              <a:t>▶ BUKA KODE LENGKAP DI GITHUB (slide_02_tools_dan_environment.dart)</a:t>
+            </a:r>
+          </a:p>
+          <a:p>
+            <a:pPr>
+              <a:defRPr sz="760">
+                <a:solidFill>
+                  <a:srgbClr val="3C3C3C"/>
+                </a:solidFill>
+                <a:latin typeface="Segoe UI"/>
+              </a:defRPr>
+            </a:pPr>
+            <a:r>
+              <a:t>💡 Buka di browser / salin source code: github.com/antonprafanto/mobile2026</a:t>
             </a:r>
           </a:p>
         </p:txBody>
@@ -9147,8 +10230,8 @@
         </p:nvSpPr>
         <p:spPr>
           <a:xfrm>
-            <a:off x="5669280" y="2176272"/>
-            <a:ext cx="5486400" cy="3977639"/>
+            <a:off x="5669280" y="2121408"/>
+            <a:ext cx="5486400" cy="3364992"/>
           </a:xfrm>
           <a:prstGeom prst="rect">
             <a:avLst/>
@@ -9162,7 +10245,7 @@
           <a:lstStyle/>
           <a:p>
             <a:pPr>
-              <a:defRPr sz="980">
+              <a:defRPr sz="919">
                 <a:solidFill>
                   <a:srgbClr val="F5F5F5"/>
                 </a:solidFill>
@@ -9207,6 +10290,142 @@
             <a:br/>
             <a:r>
               <a:t>}</a:t>
+            </a:r>
+          </a:p>
+        </p:txBody>
+      </p:sp>
+      <p:sp>
+        <p:nvSpPr>
+          <p:cNvPr id="15" name="Rectangle 14"/>
+          <p:cNvSpPr/>
+          <p:nvPr/>
+        </p:nvSpPr>
+        <p:spPr>
+          <a:xfrm>
+            <a:off x="5660136" y="5669280"/>
+            <a:ext cx="5608015" cy="548640"/>
+          </a:xfrm>
+          <a:prstGeom prst="rect">
+            <a:avLst/>
+          </a:prstGeom>
+          <a:solidFill>
+            <a:srgbClr val="000000"/>
+          </a:solidFill>
+          <a:ln>
+            <a:noFill/>
+          </a:ln>
+        </p:spPr>
+        <p:style>
+          <a:lnRef idx="1">
+            <a:schemeClr val="accent1"/>
+          </a:lnRef>
+          <a:fillRef idx="3">
+            <a:schemeClr val="accent1"/>
+          </a:fillRef>
+          <a:effectRef idx="2">
+            <a:schemeClr val="accent1"/>
+          </a:effectRef>
+          <a:fontRef idx="minor">
+            <a:schemeClr val="lt1"/>
+          </a:fontRef>
+        </p:style>
+        <p:txBody>
+          <a:bodyPr rtlCol="0" anchor="ctr"/>
+          <a:lstStyle/>
+          <a:p>
+            <a:pPr algn="ctr"/>
+          </a:p>
+        </p:txBody>
+      </p:sp>
+      <p:sp>
+        <p:nvSpPr>
+          <p:cNvPr id="16" name="Rectangle 15"/>
+          <p:cNvSpPr/>
+          <p:nvPr/>
+        </p:nvSpPr>
+        <p:spPr>
+          <a:xfrm>
+            <a:off x="5623560" y="5632704"/>
+            <a:ext cx="5608015" cy="548640"/>
+          </a:xfrm>
+          <a:prstGeom prst="rect">
+            <a:avLst/>
+          </a:prstGeom>
+          <a:solidFill>
+            <a:srgbClr val="FFE600"/>
+          </a:solidFill>
+          <a:ln w="25400">
+            <a:solidFill>
+              <a:srgbClr val="000000"/>
+            </a:solidFill>
+          </a:ln>
+        </p:spPr>
+        <p:style>
+          <a:lnRef idx="1">
+            <a:schemeClr val="accent1"/>
+          </a:lnRef>
+          <a:fillRef idx="3">
+            <a:schemeClr val="accent1"/>
+          </a:fillRef>
+          <a:effectRef idx="2">
+            <a:schemeClr val="accent1"/>
+          </a:effectRef>
+          <a:fontRef idx="minor">
+            <a:schemeClr val="lt1"/>
+          </a:fontRef>
+        </p:style>
+        <p:txBody>
+          <a:bodyPr rtlCol="0" anchor="ctr"/>
+          <a:lstStyle/>
+          <a:p>
+            <a:pPr algn="ctr"/>
+          </a:p>
+        </p:txBody>
+      </p:sp>
+      <p:sp>
+        <p:nvSpPr>
+          <p:cNvPr id="17" name="TextBox 16"/>
+          <p:cNvSpPr txBox="1"/>
+          <p:nvPr/>
+        </p:nvSpPr>
+        <p:spPr>
+          <a:xfrm>
+            <a:off x="5696712" y="5660136"/>
+            <a:ext cx="5461711" cy="493776"/>
+          </a:xfrm>
+          <a:prstGeom prst="rect">
+            <a:avLst/>
+          </a:prstGeom>
+          <a:noFill/>
+        </p:spPr>
+        <p:txBody>
+          <a:bodyPr wrap="square">
+            <a:spAutoFit/>
+          </a:bodyPr>
+          <a:lstStyle/>
+          <a:p>
+            <a:r>
+              <a:rPr sz="960" b="1">
+                <a:solidFill>
+                  <a:srgbClr val="000000"/>
+                </a:solidFill>
+                <a:latin typeface="Segoe UI"/>
+                <a:hlinkClick r:id="rId2"/>
+              </a:rPr>
+              <a:t>▶ BUKA KODE LENGKAP DI GITHUB (slide_03_mindset_dart_logika.dart)</a:t>
+            </a:r>
+          </a:p>
+          <a:p>
+            <a:pPr>
+              <a:defRPr sz="760">
+                <a:solidFill>
+                  <a:srgbClr val="3C3C3C"/>
+                </a:solidFill>
+                <a:latin typeface="Segoe UI"/>
+              </a:defRPr>
+            </a:pPr>
+            <a:r>
+              <a:t>💡 Buka di browser / salin source code: github.com/antonprafanto/mobile2026</a:t>
             </a:r>
           </a:p>
         </p:txBody>
@@ -9829,8 +11048,8 @@
         </p:nvSpPr>
         <p:spPr>
           <a:xfrm>
-            <a:off x="5669280" y="2176272"/>
-            <a:ext cx="5486400" cy="3977639"/>
+            <a:off x="5669280" y="2121408"/>
+            <a:ext cx="5486400" cy="3364992"/>
           </a:xfrm>
           <a:prstGeom prst="rect">
             <a:avLst/>
@@ -9844,7 +11063,7 @@
           <a:lstStyle/>
           <a:p>
             <a:pPr>
-              <a:defRPr sz="980">
+              <a:defRPr sz="919">
                 <a:solidFill>
                   <a:srgbClr val="F5F5F5"/>
                 </a:solidFill>
@@ -9891,6 +11110,142 @@
             <a:br/>
             <a:r>
               <a:t>}</a:t>
+            </a:r>
+          </a:p>
+        </p:txBody>
+      </p:sp>
+      <p:sp>
+        <p:nvSpPr>
+          <p:cNvPr id="15" name="Rectangle 14"/>
+          <p:cNvSpPr/>
+          <p:nvPr/>
+        </p:nvSpPr>
+        <p:spPr>
+          <a:xfrm>
+            <a:off x="5660136" y="5669280"/>
+            <a:ext cx="5608015" cy="548640"/>
+          </a:xfrm>
+          <a:prstGeom prst="rect">
+            <a:avLst/>
+          </a:prstGeom>
+          <a:solidFill>
+            <a:srgbClr val="000000"/>
+          </a:solidFill>
+          <a:ln>
+            <a:noFill/>
+          </a:ln>
+        </p:spPr>
+        <p:style>
+          <a:lnRef idx="1">
+            <a:schemeClr val="accent1"/>
+          </a:lnRef>
+          <a:fillRef idx="3">
+            <a:schemeClr val="accent1"/>
+          </a:fillRef>
+          <a:effectRef idx="2">
+            <a:schemeClr val="accent1"/>
+          </a:effectRef>
+          <a:fontRef idx="minor">
+            <a:schemeClr val="lt1"/>
+          </a:fontRef>
+        </p:style>
+        <p:txBody>
+          <a:bodyPr rtlCol="0" anchor="ctr"/>
+          <a:lstStyle/>
+          <a:p>
+            <a:pPr algn="ctr"/>
+          </a:p>
+        </p:txBody>
+      </p:sp>
+      <p:sp>
+        <p:nvSpPr>
+          <p:cNvPr id="16" name="Rectangle 15"/>
+          <p:cNvSpPr/>
+          <p:nvPr/>
+        </p:nvSpPr>
+        <p:spPr>
+          <a:xfrm>
+            <a:off x="5623560" y="5632704"/>
+            <a:ext cx="5608015" cy="548640"/>
+          </a:xfrm>
+          <a:prstGeom prst="rect">
+            <a:avLst/>
+          </a:prstGeom>
+          <a:solidFill>
+            <a:srgbClr val="FFE600"/>
+          </a:solidFill>
+          <a:ln w="25400">
+            <a:solidFill>
+              <a:srgbClr val="000000"/>
+            </a:solidFill>
+          </a:ln>
+        </p:spPr>
+        <p:style>
+          <a:lnRef idx="1">
+            <a:schemeClr val="accent1"/>
+          </a:lnRef>
+          <a:fillRef idx="3">
+            <a:schemeClr val="accent1"/>
+          </a:fillRef>
+          <a:effectRef idx="2">
+            <a:schemeClr val="accent1"/>
+          </a:effectRef>
+          <a:fontRef idx="minor">
+            <a:schemeClr val="lt1"/>
+          </a:fontRef>
+        </p:style>
+        <p:txBody>
+          <a:bodyPr rtlCol="0" anchor="ctr"/>
+          <a:lstStyle/>
+          <a:p>
+            <a:pPr algn="ctr"/>
+          </a:p>
+        </p:txBody>
+      </p:sp>
+      <p:sp>
+        <p:nvSpPr>
+          <p:cNvPr id="17" name="TextBox 16"/>
+          <p:cNvSpPr txBox="1"/>
+          <p:nvPr/>
+        </p:nvSpPr>
+        <p:spPr>
+          <a:xfrm>
+            <a:off x="5696712" y="5660136"/>
+            <a:ext cx="5461711" cy="493776"/>
+          </a:xfrm>
+          <a:prstGeom prst="rect">
+            <a:avLst/>
+          </a:prstGeom>
+          <a:noFill/>
+        </p:spPr>
+        <p:txBody>
+          <a:bodyPr wrap="square">
+            <a:spAutoFit/>
+          </a:bodyPr>
+          <a:lstStyle/>
+          <a:p>
+            <a:r>
+              <a:rPr sz="960" b="1">
+                <a:solidFill>
+                  <a:srgbClr val="000000"/>
+                </a:solidFill>
+                <a:latin typeface="Segoe UI"/>
+                <a:hlinkClick r:id="rId2"/>
+              </a:rPr>
+              <a:t>▶ BUKA KODE LENGKAP DI GITHUB (slide_04_variabel_dan_tipe_data.dart)</a:t>
+            </a:r>
+          </a:p>
+          <a:p>
+            <a:pPr>
+              <a:defRPr sz="760">
+                <a:solidFill>
+                  <a:srgbClr val="3C3C3C"/>
+                </a:solidFill>
+                <a:latin typeface="Segoe UI"/>
+              </a:defRPr>
+            </a:pPr>
+            <a:r>
+              <a:t>💡 Buka di browser / salin source code: github.com/antonprafanto/mobile2026</a:t>
             </a:r>
           </a:p>
         </p:txBody>
@@ -10497,8 +11852,8 @@
         </p:nvSpPr>
         <p:spPr>
           <a:xfrm>
-            <a:off x="5669280" y="2176272"/>
-            <a:ext cx="5486400" cy="3977639"/>
+            <a:off x="5669280" y="2121408"/>
+            <a:ext cx="5486400" cy="3364992"/>
           </a:xfrm>
           <a:prstGeom prst="rect">
             <a:avLst/>
@@ -10512,7 +11867,7 @@
           <a:lstStyle/>
           <a:p>
             <a:pPr>
-              <a:defRPr sz="980">
+              <a:defRPr sz="919">
                 <a:solidFill>
                   <a:srgbClr val="F5F5F5"/>
                 </a:solidFill>
@@ -10559,6 +11914,142 @@
             <a:br/>
             <a:r>
               <a:t>}</a:t>
+            </a:r>
+          </a:p>
+        </p:txBody>
+      </p:sp>
+      <p:sp>
+        <p:nvSpPr>
+          <p:cNvPr id="15" name="Rectangle 14"/>
+          <p:cNvSpPr/>
+          <p:nvPr/>
+        </p:nvSpPr>
+        <p:spPr>
+          <a:xfrm>
+            <a:off x="5660136" y="5669280"/>
+            <a:ext cx="5608015" cy="548640"/>
+          </a:xfrm>
+          <a:prstGeom prst="rect">
+            <a:avLst/>
+          </a:prstGeom>
+          <a:solidFill>
+            <a:srgbClr val="000000"/>
+          </a:solidFill>
+          <a:ln>
+            <a:noFill/>
+          </a:ln>
+        </p:spPr>
+        <p:style>
+          <a:lnRef idx="1">
+            <a:schemeClr val="accent1"/>
+          </a:lnRef>
+          <a:fillRef idx="3">
+            <a:schemeClr val="accent1"/>
+          </a:fillRef>
+          <a:effectRef idx="2">
+            <a:schemeClr val="accent1"/>
+          </a:effectRef>
+          <a:fontRef idx="minor">
+            <a:schemeClr val="lt1"/>
+          </a:fontRef>
+        </p:style>
+        <p:txBody>
+          <a:bodyPr rtlCol="0" anchor="ctr"/>
+          <a:lstStyle/>
+          <a:p>
+            <a:pPr algn="ctr"/>
+          </a:p>
+        </p:txBody>
+      </p:sp>
+      <p:sp>
+        <p:nvSpPr>
+          <p:cNvPr id="16" name="Rectangle 15"/>
+          <p:cNvSpPr/>
+          <p:nvPr/>
+        </p:nvSpPr>
+        <p:spPr>
+          <a:xfrm>
+            <a:off x="5623560" y="5632704"/>
+            <a:ext cx="5608015" cy="548640"/>
+          </a:xfrm>
+          <a:prstGeom prst="rect">
+            <a:avLst/>
+          </a:prstGeom>
+          <a:solidFill>
+            <a:srgbClr val="FFE600"/>
+          </a:solidFill>
+          <a:ln w="25400">
+            <a:solidFill>
+              <a:srgbClr val="000000"/>
+            </a:solidFill>
+          </a:ln>
+        </p:spPr>
+        <p:style>
+          <a:lnRef idx="1">
+            <a:schemeClr val="accent1"/>
+          </a:lnRef>
+          <a:fillRef idx="3">
+            <a:schemeClr val="accent1"/>
+          </a:fillRef>
+          <a:effectRef idx="2">
+            <a:schemeClr val="accent1"/>
+          </a:effectRef>
+          <a:fontRef idx="minor">
+            <a:schemeClr val="lt1"/>
+          </a:fontRef>
+        </p:style>
+        <p:txBody>
+          <a:bodyPr rtlCol="0" anchor="ctr"/>
+          <a:lstStyle/>
+          <a:p>
+            <a:pPr algn="ctr"/>
+          </a:p>
+        </p:txBody>
+      </p:sp>
+      <p:sp>
+        <p:nvSpPr>
+          <p:cNvPr id="17" name="TextBox 16"/>
+          <p:cNvSpPr txBox="1"/>
+          <p:nvPr/>
+        </p:nvSpPr>
+        <p:spPr>
+          <a:xfrm>
+            <a:off x="5696712" y="5660136"/>
+            <a:ext cx="5461711" cy="493776"/>
+          </a:xfrm>
+          <a:prstGeom prst="rect">
+            <a:avLst/>
+          </a:prstGeom>
+          <a:noFill/>
+        </p:spPr>
+        <p:txBody>
+          <a:bodyPr wrap="square">
+            <a:spAutoFit/>
+          </a:bodyPr>
+          <a:lstStyle/>
+          <a:p>
+            <a:r>
+              <a:rPr sz="960" b="1">
+                <a:solidFill>
+                  <a:srgbClr val="000000"/>
+                </a:solidFill>
+                <a:latin typeface="Segoe UI"/>
+                <a:hlinkClick r:id="rId2"/>
+              </a:rPr>
+              <a:t>▶ BUKA KODE LENGKAP DI GITHUB (slide_05_sound_null_safety.dart)</a:t>
+            </a:r>
+          </a:p>
+          <a:p>
+            <a:pPr>
+              <a:defRPr sz="760">
+                <a:solidFill>
+                  <a:srgbClr val="3C3C3C"/>
+                </a:solidFill>
+                <a:latin typeface="Segoe UI"/>
+              </a:defRPr>
+            </a:pPr>
+            <a:r>
+              <a:t>💡 Buka di browser / salin source code: github.com/antonprafanto/mobile2026</a:t>
             </a:r>
           </a:p>
         </p:txBody>
@@ -11165,8 +12656,8 @@
         </p:nvSpPr>
         <p:spPr>
           <a:xfrm>
-            <a:off x="5669280" y="2176272"/>
-            <a:ext cx="5486400" cy="3977639"/>
+            <a:off x="5669280" y="2121408"/>
+            <a:ext cx="5486400" cy="3364992"/>
           </a:xfrm>
           <a:prstGeom prst="rect">
             <a:avLst/>
@@ -11180,7 +12671,7 @@
           <a:lstStyle/>
           <a:p>
             <a:pPr>
-              <a:defRPr sz="980">
+              <a:defRPr sz="919">
                 <a:solidFill>
                   <a:srgbClr val="F5F5F5"/>
                 </a:solidFill>
@@ -11236,6 +12727,142 @@
             <a:br/>
             <a:r>
               <a:t>}</a:t>
+            </a:r>
+          </a:p>
+        </p:txBody>
+      </p:sp>
+      <p:sp>
+        <p:nvSpPr>
+          <p:cNvPr id="15" name="Rectangle 14"/>
+          <p:cNvSpPr/>
+          <p:nvPr/>
+        </p:nvSpPr>
+        <p:spPr>
+          <a:xfrm>
+            <a:off x="5660136" y="5669280"/>
+            <a:ext cx="5608015" cy="548640"/>
+          </a:xfrm>
+          <a:prstGeom prst="rect">
+            <a:avLst/>
+          </a:prstGeom>
+          <a:solidFill>
+            <a:srgbClr val="000000"/>
+          </a:solidFill>
+          <a:ln>
+            <a:noFill/>
+          </a:ln>
+        </p:spPr>
+        <p:style>
+          <a:lnRef idx="1">
+            <a:schemeClr val="accent1"/>
+          </a:lnRef>
+          <a:fillRef idx="3">
+            <a:schemeClr val="accent1"/>
+          </a:fillRef>
+          <a:effectRef idx="2">
+            <a:schemeClr val="accent1"/>
+          </a:effectRef>
+          <a:fontRef idx="minor">
+            <a:schemeClr val="lt1"/>
+          </a:fontRef>
+        </p:style>
+        <p:txBody>
+          <a:bodyPr rtlCol="0" anchor="ctr"/>
+          <a:lstStyle/>
+          <a:p>
+            <a:pPr algn="ctr"/>
+          </a:p>
+        </p:txBody>
+      </p:sp>
+      <p:sp>
+        <p:nvSpPr>
+          <p:cNvPr id="16" name="Rectangle 15"/>
+          <p:cNvSpPr/>
+          <p:nvPr/>
+        </p:nvSpPr>
+        <p:spPr>
+          <a:xfrm>
+            <a:off x="5623560" y="5632704"/>
+            <a:ext cx="5608015" cy="548640"/>
+          </a:xfrm>
+          <a:prstGeom prst="rect">
+            <a:avLst/>
+          </a:prstGeom>
+          <a:solidFill>
+            <a:srgbClr val="FFE600"/>
+          </a:solidFill>
+          <a:ln w="25400">
+            <a:solidFill>
+              <a:srgbClr val="000000"/>
+            </a:solidFill>
+          </a:ln>
+        </p:spPr>
+        <p:style>
+          <a:lnRef idx="1">
+            <a:schemeClr val="accent1"/>
+          </a:lnRef>
+          <a:fillRef idx="3">
+            <a:schemeClr val="accent1"/>
+          </a:fillRef>
+          <a:effectRef idx="2">
+            <a:schemeClr val="accent1"/>
+          </a:effectRef>
+          <a:fontRef idx="minor">
+            <a:schemeClr val="lt1"/>
+          </a:fontRef>
+        </p:style>
+        <p:txBody>
+          <a:bodyPr rtlCol="0" anchor="ctr"/>
+          <a:lstStyle/>
+          <a:p>
+            <a:pPr algn="ctr"/>
+          </a:p>
+        </p:txBody>
+      </p:sp>
+      <p:sp>
+        <p:nvSpPr>
+          <p:cNvPr id="17" name="TextBox 16"/>
+          <p:cNvSpPr txBox="1"/>
+          <p:nvPr/>
+        </p:nvSpPr>
+        <p:spPr>
+          <a:xfrm>
+            <a:off x="5696712" y="5660136"/>
+            <a:ext cx="5461711" cy="493776"/>
+          </a:xfrm>
+          <a:prstGeom prst="rect">
+            <a:avLst/>
+          </a:prstGeom>
+          <a:noFill/>
+        </p:spPr>
+        <p:txBody>
+          <a:bodyPr wrap="square">
+            <a:spAutoFit/>
+          </a:bodyPr>
+          <a:lstStyle/>
+          <a:p>
+            <a:r>
+              <a:rPr sz="960" b="1">
+                <a:solidFill>
+                  <a:srgbClr val="000000"/>
+                </a:solidFill>
+                <a:latin typeface="Segoe UI"/>
+                <a:hlinkClick r:id="rId2"/>
+              </a:rPr>
+              <a:t>▶ BUKA KODE LENGKAP DI GITHUB (slide_06_operator_penjinak_null.dart)</a:t>
+            </a:r>
+          </a:p>
+          <a:p>
+            <a:pPr>
+              <a:defRPr sz="760">
+                <a:solidFill>
+                  <a:srgbClr val="3C3C3C"/>
+                </a:solidFill>
+                <a:latin typeface="Segoe UI"/>
+              </a:defRPr>
+            </a:pPr>
+            <a:r>
+              <a:t>💡 Buka di browser / salin source code: github.com/antonprafanto/mobile2026</a:t>
             </a:r>
           </a:p>
         </p:txBody>
@@ -11842,8 +13469,8 @@
         </p:nvSpPr>
         <p:spPr>
           <a:xfrm>
-            <a:off x="5669280" y="2176272"/>
-            <a:ext cx="5486400" cy="3977639"/>
+            <a:off x="5669280" y="2121408"/>
+            <a:ext cx="5486400" cy="3364992"/>
           </a:xfrm>
           <a:prstGeom prst="rect">
             <a:avLst/>
@@ -11857,7 +13484,7 @@
           <a:lstStyle/>
           <a:p>
             <a:pPr>
-              <a:defRPr sz="980">
+              <a:defRPr sz="919">
                 <a:solidFill>
                   <a:srgbClr val="F5F5F5"/>
                 </a:solidFill>
@@ -11896,6 +13523,142 @@
             <a:br/>
             <a:r>
               <a:t>void main() =&gt; print('Hasil 10 x 2 = ${kaliDua(10)}');</a:t>
+            </a:r>
+          </a:p>
+        </p:txBody>
+      </p:sp>
+      <p:sp>
+        <p:nvSpPr>
+          <p:cNvPr id="15" name="Rectangle 14"/>
+          <p:cNvSpPr/>
+          <p:nvPr/>
+        </p:nvSpPr>
+        <p:spPr>
+          <a:xfrm>
+            <a:off x="5660136" y="5669280"/>
+            <a:ext cx="5608015" cy="548640"/>
+          </a:xfrm>
+          <a:prstGeom prst="rect">
+            <a:avLst/>
+          </a:prstGeom>
+          <a:solidFill>
+            <a:srgbClr val="000000"/>
+          </a:solidFill>
+          <a:ln>
+            <a:noFill/>
+          </a:ln>
+        </p:spPr>
+        <p:style>
+          <a:lnRef idx="1">
+            <a:schemeClr val="accent1"/>
+          </a:lnRef>
+          <a:fillRef idx="3">
+            <a:schemeClr val="accent1"/>
+          </a:fillRef>
+          <a:effectRef idx="2">
+            <a:schemeClr val="accent1"/>
+          </a:effectRef>
+          <a:fontRef idx="minor">
+            <a:schemeClr val="lt1"/>
+          </a:fontRef>
+        </p:style>
+        <p:txBody>
+          <a:bodyPr rtlCol="0" anchor="ctr"/>
+          <a:lstStyle/>
+          <a:p>
+            <a:pPr algn="ctr"/>
+          </a:p>
+        </p:txBody>
+      </p:sp>
+      <p:sp>
+        <p:nvSpPr>
+          <p:cNvPr id="16" name="Rectangle 15"/>
+          <p:cNvSpPr/>
+          <p:nvPr/>
+        </p:nvSpPr>
+        <p:spPr>
+          <a:xfrm>
+            <a:off x="5623560" y="5632704"/>
+            <a:ext cx="5608015" cy="548640"/>
+          </a:xfrm>
+          <a:prstGeom prst="rect">
+            <a:avLst/>
+          </a:prstGeom>
+          <a:solidFill>
+            <a:srgbClr val="FFE600"/>
+          </a:solidFill>
+          <a:ln w="25400">
+            <a:solidFill>
+              <a:srgbClr val="000000"/>
+            </a:solidFill>
+          </a:ln>
+        </p:spPr>
+        <p:style>
+          <a:lnRef idx="1">
+            <a:schemeClr val="accent1"/>
+          </a:lnRef>
+          <a:fillRef idx="3">
+            <a:schemeClr val="accent1"/>
+          </a:fillRef>
+          <a:effectRef idx="2">
+            <a:schemeClr val="accent1"/>
+          </a:effectRef>
+          <a:fontRef idx="minor">
+            <a:schemeClr val="lt1"/>
+          </a:fontRef>
+        </p:style>
+        <p:txBody>
+          <a:bodyPr rtlCol="0" anchor="ctr"/>
+          <a:lstStyle/>
+          <a:p>
+            <a:pPr algn="ctr"/>
+          </a:p>
+        </p:txBody>
+      </p:sp>
+      <p:sp>
+        <p:nvSpPr>
+          <p:cNvPr id="17" name="TextBox 16"/>
+          <p:cNvSpPr txBox="1"/>
+          <p:nvPr/>
+        </p:nvSpPr>
+        <p:spPr>
+          <a:xfrm>
+            <a:off x="5696712" y="5660136"/>
+            <a:ext cx="5461711" cy="493776"/>
+          </a:xfrm>
+          <a:prstGeom prst="rect">
+            <a:avLst/>
+          </a:prstGeom>
+          <a:noFill/>
+        </p:spPr>
+        <p:txBody>
+          <a:bodyPr wrap="square">
+            <a:spAutoFit/>
+          </a:bodyPr>
+          <a:lstStyle/>
+          <a:p>
+            <a:r>
+              <a:rPr sz="960" b="1">
+                <a:solidFill>
+                  <a:srgbClr val="000000"/>
+                </a:solidFill>
+                <a:latin typeface="Segoe UI"/>
+                <a:hlinkClick r:id="rId2"/>
+              </a:rPr>
+              <a:t>▶ BUKA KODE LENGKAP DI GITHUB (slide_07_fat_arrow_functions.dart)</a:t>
+            </a:r>
+          </a:p>
+          <a:p>
+            <a:pPr>
+              <a:defRPr sz="760">
+                <a:solidFill>
+                  <a:srgbClr val="3C3C3C"/>
+                </a:solidFill>
+                <a:latin typeface="Segoe UI"/>
+              </a:defRPr>
+            </a:pPr>
+            <a:r>
+              <a:t>💡 Buka di browser / salin source code: github.com/antonprafanto/mobile2026</a:t>
             </a:r>
           </a:p>
         </p:txBody>
@@ -12502,8 +14265,8 @@
         </p:nvSpPr>
         <p:spPr>
           <a:xfrm>
-            <a:off x="5669280" y="2176272"/>
-            <a:ext cx="5486400" cy="3977639"/>
+            <a:off x="5669280" y="2121408"/>
+            <a:ext cx="5486400" cy="3364992"/>
           </a:xfrm>
           <a:prstGeom prst="rect">
             <a:avLst/>
@@ -12517,7 +14280,7 @@
           <a:lstStyle/>
           <a:p>
             <a:pPr>
-              <a:defRPr sz="980">
+              <a:defRPr sz="919">
                 <a:solidFill>
                   <a:srgbClr val="F5F5F5"/>
                 </a:solidFill>
@@ -12588,6 +14351,142 @@
             <a:br/>
             <a:r>
               <a:t>}</a:t>
+            </a:r>
+          </a:p>
+        </p:txBody>
+      </p:sp>
+      <p:sp>
+        <p:nvSpPr>
+          <p:cNvPr id="15" name="Rectangle 14"/>
+          <p:cNvSpPr/>
+          <p:nvPr/>
+        </p:nvSpPr>
+        <p:spPr>
+          <a:xfrm>
+            <a:off x="5660136" y="5669280"/>
+            <a:ext cx="5608015" cy="548640"/>
+          </a:xfrm>
+          <a:prstGeom prst="rect">
+            <a:avLst/>
+          </a:prstGeom>
+          <a:solidFill>
+            <a:srgbClr val="000000"/>
+          </a:solidFill>
+          <a:ln>
+            <a:noFill/>
+          </a:ln>
+        </p:spPr>
+        <p:style>
+          <a:lnRef idx="1">
+            <a:schemeClr val="accent1"/>
+          </a:lnRef>
+          <a:fillRef idx="3">
+            <a:schemeClr val="accent1"/>
+          </a:fillRef>
+          <a:effectRef idx="2">
+            <a:schemeClr val="accent1"/>
+          </a:effectRef>
+          <a:fontRef idx="minor">
+            <a:schemeClr val="lt1"/>
+          </a:fontRef>
+        </p:style>
+        <p:txBody>
+          <a:bodyPr rtlCol="0" anchor="ctr"/>
+          <a:lstStyle/>
+          <a:p>
+            <a:pPr algn="ctr"/>
+          </a:p>
+        </p:txBody>
+      </p:sp>
+      <p:sp>
+        <p:nvSpPr>
+          <p:cNvPr id="16" name="Rectangle 15"/>
+          <p:cNvSpPr/>
+          <p:nvPr/>
+        </p:nvSpPr>
+        <p:spPr>
+          <a:xfrm>
+            <a:off x="5623560" y="5632704"/>
+            <a:ext cx="5608015" cy="548640"/>
+          </a:xfrm>
+          <a:prstGeom prst="rect">
+            <a:avLst/>
+          </a:prstGeom>
+          <a:solidFill>
+            <a:srgbClr val="FFE600"/>
+          </a:solidFill>
+          <a:ln w="25400">
+            <a:solidFill>
+              <a:srgbClr val="000000"/>
+            </a:solidFill>
+          </a:ln>
+        </p:spPr>
+        <p:style>
+          <a:lnRef idx="1">
+            <a:schemeClr val="accent1"/>
+          </a:lnRef>
+          <a:fillRef idx="3">
+            <a:schemeClr val="accent1"/>
+          </a:fillRef>
+          <a:effectRef idx="2">
+            <a:schemeClr val="accent1"/>
+          </a:effectRef>
+          <a:fontRef idx="minor">
+            <a:schemeClr val="lt1"/>
+          </a:fontRef>
+        </p:style>
+        <p:txBody>
+          <a:bodyPr rtlCol="0" anchor="ctr"/>
+          <a:lstStyle/>
+          <a:p>
+            <a:pPr algn="ctr"/>
+          </a:p>
+        </p:txBody>
+      </p:sp>
+      <p:sp>
+        <p:nvSpPr>
+          <p:cNvPr id="17" name="TextBox 16"/>
+          <p:cNvSpPr txBox="1"/>
+          <p:nvPr/>
+        </p:nvSpPr>
+        <p:spPr>
+          <a:xfrm>
+            <a:off x="5696712" y="5660136"/>
+            <a:ext cx="5461711" cy="493776"/>
+          </a:xfrm>
+          <a:prstGeom prst="rect">
+            <a:avLst/>
+          </a:prstGeom>
+          <a:noFill/>
+        </p:spPr>
+        <p:txBody>
+          <a:bodyPr wrap="square">
+            <a:spAutoFit/>
+          </a:bodyPr>
+          <a:lstStyle/>
+          <a:p>
+            <a:r>
+              <a:rPr sz="960" b="1">
+                <a:solidFill>
+                  <a:srgbClr val="000000"/>
+                </a:solidFill>
+                <a:latin typeface="Segoe UI"/>
+                <a:hlinkClick r:id="rId2"/>
+              </a:rPr>
+              <a:t>▶ BUKA KODE LENGKAP DI GITHUB (slide_08_oop_named_parameters.dart)</a:t>
+            </a:r>
+          </a:p>
+          <a:p>
+            <a:pPr>
+              <a:defRPr sz="760">
+                <a:solidFill>
+                  <a:srgbClr val="3C3C3C"/>
+                </a:solidFill>
+                <a:latin typeface="Segoe UI"/>
+              </a:defRPr>
+            </a:pPr>
+            <a:r>
+              <a:t>💡 Buka di browser / salin source code: github.com/antonprafanto/mobile2026</a:t>
             </a:r>
           </a:p>
         </p:txBody>
@@ -13194,8 +15093,8 @@
         </p:nvSpPr>
         <p:spPr>
           <a:xfrm>
-            <a:off x="5669280" y="2176272"/>
-            <a:ext cx="5486400" cy="3977639"/>
+            <a:off x="5669280" y="2121408"/>
+            <a:ext cx="5486400" cy="3364992"/>
           </a:xfrm>
           <a:prstGeom prst="rect">
             <a:avLst/>
@@ -13209,7 +15108,7 @@
           <a:lstStyle/>
           <a:p>
             <a:pPr>
-              <a:defRPr sz="980">
+              <a:defRPr sz="919">
                 <a:solidFill>
                   <a:srgbClr val="F5F5F5"/>
                 </a:solidFill>
@@ -13268,6 +15167,142 @@
             <a:br/>
             <a:r>
               <a:t>}</a:t>
+            </a:r>
+          </a:p>
+        </p:txBody>
+      </p:sp>
+      <p:sp>
+        <p:nvSpPr>
+          <p:cNvPr id="15" name="Rectangle 14"/>
+          <p:cNvSpPr/>
+          <p:nvPr/>
+        </p:nvSpPr>
+        <p:spPr>
+          <a:xfrm>
+            <a:off x="5660136" y="5669280"/>
+            <a:ext cx="5608015" cy="548640"/>
+          </a:xfrm>
+          <a:prstGeom prst="rect">
+            <a:avLst/>
+          </a:prstGeom>
+          <a:solidFill>
+            <a:srgbClr val="000000"/>
+          </a:solidFill>
+          <a:ln>
+            <a:noFill/>
+          </a:ln>
+        </p:spPr>
+        <p:style>
+          <a:lnRef idx="1">
+            <a:schemeClr val="accent1"/>
+          </a:lnRef>
+          <a:fillRef idx="3">
+            <a:schemeClr val="accent1"/>
+          </a:fillRef>
+          <a:effectRef idx="2">
+            <a:schemeClr val="accent1"/>
+          </a:effectRef>
+          <a:fontRef idx="minor">
+            <a:schemeClr val="lt1"/>
+          </a:fontRef>
+        </p:style>
+        <p:txBody>
+          <a:bodyPr rtlCol="0" anchor="ctr"/>
+          <a:lstStyle/>
+          <a:p>
+            <a:pPr algn="ctr"/>
+          </a:p>
+        </p:txBody>
+      </p:sp>
+      <p:sp>
+        <p:nvSpPr>
+          <p:cNvPr id="16" name="Rectangle 15"/>
+          <p:cNvSpPr/>
+          <p:nvPr/>
+        </p:nvSpPr>
+        <p:spPr>
+          <a:xfrm>
+            <a:off x="5623560" y="5632704"/>
+            <a:ext cx="5608015" cy="548640"/>
+          </a:xfrm>
+          <a:prstGeom prst="rect">
+            <a:avLst/>
+          </a:prstGeom>
+          <a:solidFill>
+            <a:srgbClr val="FFE600"/>
+          </a:solidFill>
+          <a:ln w="25400">
+            <a:solidFill>
+              <a:srgbClr val="000000"/>
+            </a:solidFill>
+          </a:ln>
+        </p:spPr>
+        <p:style>
+          <a:lnRef idx="1">
+            <a:schemeClr val="accent1"/>
+          </a:lnRef>
+          <a:fillRef idx="3">
+            <a:schemeClr val="accent1"/>
+          </a:fillRef>
+          <a:effectRef idx="2">
+            <a:schemeClr val="accent1"/>
+          </a:effectRef>
+          <a:fontRef idx="minor">
+            <a:schemeClr val="lt1"/>
+          </a:fontRef>
+        </p:style>
+        <p:txBody>
+          <a:bodyPr rtlCol="0" anchor="ctr"/>
+          <a:lstStyle/>
+          <a:p>
+            <a:pPr algn="ctr"/>
+          </a:p>
+        </p:txBody>
+      </p:sp>
+      <p:sp>
+        <p:nvSpPr>
+          <p:cNvPr id="17" name="TextBox 16"/>
+          <p:cNvSpPr txBox="1"/>
+          <p:nvPr/>
+        </p:nvSpPr>
+        <p:spPr>
+          <a:xfrm>
+            <a:off x="5696712" y="5660136"/>
+            <a:ext cx="5461711" cy="493776"/>
+          </a:xfrm>
+          <a:prstGeom prst="rect">
+            <a:avLst/>
+          </a:prstGeom>
+          <a:noFill/>
+        </p:spPr>
+        <p:txBody>
+          <a:bodyPr wrap="square">
+            <a:spAutoFit/>
+          </a:bodyPr>
+          <a:lstStyle/>
+          <a:p>
+            <a:r>
+              <a:rPr sz="960" b="1">
+                <a:solidFill>
+                  <a:srgbClr val="000000"/>
+                </a:solidFill>
+                <a:latin typeface="Segoe UI"/>
+                <a:hlinkClick r:id="rId2"/>
+              </a:rPr>
+              <a:t>▶ BUKA KODE LENGKAP DI GITHUB (slide_09_mixins_with_keyword.dart)</a:t>
+            </a:r>
+          </a:p>
+          <a:p>
+            <a:pPr>
+              <a:defRPr sz="760">
+                <a:solidFill>
+                  <a:srgbClr val="3C3C3C"/>
+                </a:solidFill>
+                <a:latin typeface="Segoe UI"/>
+              </a:defRPr>
+            </a:pPr>
+            <a:r>
+              <a:t>💡 Buka di browser / salin source code: github.com/antonprafanto/mobile2026</a:t>
             </a:r>
           </a:p>
         </p:txBody>

</xml_diff>